<commit_message>
Retitle engineering study to highlight large language models
</commit_message>
<xml_diff>
--- a/docs/materials/ai4e-poster.pptx
+++ b/docs/materials/ai4e-poster.pptx
@@ -2,13 +2,13 @@
 <file path=ppt/presentation.xml><?xml version="1.0" encoding="utf-8"?>
 <p:presentation xmlns:p="http://schemas.openxmlformats.org/presentationml/2006/main">
   <p:sldMasterIdLst>
-    <p:sldMasterId xmlns:r="http://schemas.openxmlformats.org/officeDocument/2006/relationships" id="2147483648" r:id="R38db40cea8e146e3"/>
+    <p:sldMasterId xmlns:r="http://schemas.openxmlformats.org/officeDocument/2006/relationships" id="2147483648" r:id="Raac42e8324af4e87"/>
   </p:sldMasterIdLst>
   <p:notesMasterIdLst>
-    <p:notesMasterId xmlns:r="http://schemas.openxmlformats.org/officeDocument/2006/relationships" r:id="R505ddd32e7864b83"/>
+    <p:notesMasterId xmlns:r="http://schemas.openxmlformats.org/officeDocument/2006/relationships" r:id="Rd97087be27bc439e"/>
   </p:notesMasterIdLst>
   <p:sldIdLst>
-    <p:sldId xmlns:r="http://schemas.openxmlformats.org/officeDocument/2006/relationships" id="256" r:id="R2ffec778ab1e44a4"/>
+    <p:sldId xmlns:r="http://schemas.openxmlformats.org/officeDocument/2006/relationships" id="256" r:id="R596b88c725a4484f"/>
   </p:sldIdLst>
   <p:sldSz cx="21599525" cy="32399288"/>
   <p:notesSz cx="6858000" cy="9144000"/>
@@ -621,7 +621,7 @@
   </p:cSld>
   <p:clrMap bg1="lt1" tx1="dk1" bg2="lt2" tx2="dk2" accent1="accent1" accent2="accent2" accent3="accent3" accent4="accent4" accent5="accent5" accent6="accent6" hlink="hlink" folHlink="folHlink"/>
   <p:sldLayoutIdLst>
-    <p:sldLayoutId xmlns:r="http://schemas.openxmlformats.org/officeDocument/2006/relationships" id="2147483649" r:id="R427ac7ba2ce34f16"/>
+    <p:sldLayoutId xmlns:r="http://schemas.openxmlformats.org/officeDocument/2006/relationships" id="2147483649" r:id="R8e923597495a4a73"/>
   </p:sldLayoutIdLst>
   <p:txStyles>
     <p:titleStyle>
@@ -1464,7 +1464,7 @@
           <p:cNvPr id="52" name="图片 51">
             <a:extLst xmlns:a="http://schemas.openxmlformats.org/drawingml/2006/main">
               <a:ext uri="{FF2B5EF4-FFF2-40B4-BE49-F238E27FC236}">
-                <a16:creationId xmlns:a16="http://schemas.microsoft.com/office/drawing/2014/main" id="{B92F5448-D05E-4B94-8565-775EF1BC4086}"/>
+                <a16:creationId xmlns:a16="http://schemas.microsoft.com/office/drawing/2014/main" id="{2E34FA43-C718-4D7E-A4F0-11C40DC612EA}"/>
               </a:ext>
             </a:extLst>
           </p:cNvPr>
@@ -1474,7 +1474,7 @@
           <p:nvPr/>
         </p:nvPicPr>
         <p:blipFill>
-          <a:blip xmlns:r="http://schemas.openxmlformats.org/officeDocument/2006/relationships" xmlns:a="http://schemas.openxmlformats.org/drawingml/2006/main" r:embed="Rf112c39e671d4bb6"/>
+          <a:blip xmlns:r="http://schemas.openxmlformats.org/officeDocument/2006/relationships" xmlns:a="http://schemas.openxmlformats.org/drawingml/2006/main" r:embed="R766e7530cfac473d"/>
           <a:srcRect xmlns:a="http://schemas.openxmlformats.org/drawingml/2006/main" l="0" t="1750" r="0" b="1750"/>
           <a:stretch xmlns:a="http://schemas.openxmlformats.org/drawingml/2006/main">
             <a:fillRect l="0" t="0" r="0" b="0"/>
@@ -1822,7 +1822,7 @@
           <p:cNvPr id="59" name="图片 58">
             <a:extLst xmlns:a="http://schemas.openxmlformats.org/drawingml/2006/main">
               <a:ext uri="{FF2B5EF4-FFF2-40B4-BE49-F238E27FC236}">
-                <a16:creationId xmlns:a16="http://schemas.microsoft.com/office/drawing/2014/main" id="{18492E58-F531-4CDC-B04C-B7A39CA86AF4}"/>
+                <a16:creationId xmlns:a16="http://schemas.microsoft.com/office/drawing/2014/main" id="{E9CFF15B-ED7F-4F42-8FF9-65E44A99446F}"/>
               </a:ext>
             </a:extLst>
           </p:cNvPr>
@@ -1832,7 +1832,7 @@
           <p:nvPr/>
         </p:nvPicPr>
         <p:blipFill>
-          <a:blip xmlns:r="http://schemas.openxmlformats.org/officeDocument/2006/relationships" xmlns:a="http://schemas.openxmlformats.org/drawingml/2006/main" r:embed="Rb2ccce439e324c5c"/>
+          <a:blip xmlns:r="http://schemas.openxmlformats.org/officeDocument/2006/relationships" xmlns:a="http://schemas.openxmlformats.org/drawingml/2006/main" r:embed="Rda1d0d5356584620"/>
           <a:srcRect xmlns:a="http://schemas.openxmlformats.org/drawingml/2006/main" l="500" t="23500" r="500" b="23500"/>
           <a:stretch xmlns:a="http://schemas.openxmlformats.org/drawingml/2006/main"/>
         </p:blipFill>
@@ -1851,7 +1851,7 @@
           <p:cNvPr id="60" name="图片 59">
             <a:extLst xmlns:a="http://schemas.openxmlformats.org/drawingml/2006/main">
               <a:ext uri="{FF2B5EF4-FFF2-40B4-BE49-F238E27FC236}">
-                <a16:creationId xmlns:a16="http://schemas.microsoft.com/office/drawing/2014/main" id="{51210DE1-A4D2-4D7E-9FFB-A91113932F65}"/>
+                <a16:creationId xmlns:a16="http://schemas.microsoft.com/office/drawing/2014/main" id="{BCA6434A-1B69-4086-821B-D4CA4FBA3BDA}"/>
               </a:ext>
             </a:extLst>
           </p:cNvPr>
@@ -1861,7 +1861,7 @@
           <p:nvPr/>
         </p:nvPicPr>
         <p:blipFill>
-          <a:blip xmlns:r="http://schemas.openxmlformats.org/officeDocument/2006/relationships" xmlns:a="http://schemas.openxmlformats.org/drawingml/2006/main" r:embed="Ra3d1039d4a2d4a1b"/>
+          <a:blip xmlns:r="http://schemas.openxmlformats.org/officeDocument/2006/relationships" xmlns:a="http://schemas.openxmlformats.org/drawingml/2006/main" r:embed="R7220fffe3b1f4b92"/>
           <a:stretch xmlns:a="http://schemas.openxmlformats.org/drawingml/2006/main"/>
         </p:blipFill>
         <p:spPr>
@@ -1989,7 +1989,7 @@
                 <a:ea typeface="Microsoft YaHei"/>
                 <a:cs typeface="Microsoft YaHei"/>
               </a:rPr>
-              <a:t>OpenTrust：工程设计中可执行反馈的作用与边界</a:t>
+              <a:t>大语言模型辅助工程设计中的执行反馈与审查</a:t>
             </a:r>
           </a:p>
           <a:p xmlns:a="http://schemas.openxmlformats.org/drawingml/2006/main">
@@ -2016,7 +2016,7 @@
                 <a:ea typeface="Microsoft YaHei"/>
                 <a:cs typeface="Microsoft YaHei"/>
               </a:rPr>
-              <a:t>配电与供水设备控制设计的同起点评估</a:t>
+              <a:t>——配电与供水网络的对照研究</a:t>
             </a:r>
           </a:p>
         </p:txBody>
@@ -3708,7 +3708,7 @@
           <p:cNvPr id="86" name="表格 85">
             <a:extLst xmlns:a="http://schemas.openxmlformats.org/drawingml/2006/main">
               <a:ext uri="{FF2B5EF4-FFF2-40B4-BE49-F238E27FC236}">
-                <a16:creationId xmlns:a16="http://schemas.microsoft.com/office/drawing/2014/main" id="{3C352A97-1DD1-4A59-B94F-F9D8B301835B}"/>
+                <a16:creationId xmlns:a16="http://schemas.microsoft.com/office/drawing/2014/main" id="{6516F009-4AE3-4E38-8BCC-449B43A2830F}"/>
               </a:ext>
             </a:extLst>
           </p:cNvPr>
@@ -5015,7 +5015,7 @@
           <p:cNvPr id="87" name="method-stage-1">
             <a:extLst xmlns:a="http://schemas.openxmlformats.org/drawingml/2006/main">
               <a:ext uri="{FF2B5EF4-FFF2-40B4-BE49-F238E27FC236}">
-                <a16:creationId xmlns:a16="http://schemas.microsoft.com/office/drawing/2014/main" id="{09790F24-F84B-4C20-B513-99588BE4208B}"/>
+                <a16:creationId xmlns:a16="http://schemas.microsoft.com/office/drawing/2014/main" id="{D947A507-6D42-4F89-A0DE-3BA3BD32D964}"/>
               </a:ext>
             </a:extLst>
           </p:cNvPr>
@@ -5047,7 +5047,7 @@
           <p:cNvPr id="88" name="stage-title-1">
             <a:extLst xmlns:a="http://schemas.openxmlformats.org/drawingml/2006/main">
               <a:ext uri="{FF2B5EF4-FFF2-40B4-BE49-F238E27FC236}">
-                <a16:creationId xmlns:a16="http://schemas.microsoft.com/office/drawing/2014/main" id="{1D73D9A9-1492-4A3C-9229-05BB6AD193BF}"/>
+                <a16:creationId xmlns:a16="http://schemas.microsoft.com/office/drawing/2014/main" id="{BCF83066-3835-4F5B-AB65-6B9117F00444}"/>
               </a:ext>
             </a:extLst>
           </p:cNvPr>
@@ -5115,7 +5115,7 @@
           <p:cNvPr id="89" name="stage-detail-1">
             <a:extLst xmlns:a="http://schemas.openxmlformats.org/drawingml/2006/main">
               <a:ext uri="{FF2B5EF4-FFF2-40B4-BE49-F238E27FC236}">
-                <a16:creationId xmlns:a16="http://schemas.microsoft.com/office/drawing/2014/main" id="{867869CD-9717-4E3F-9351-DC55FA0AA456}"/>
+                <a16:creationId xmlns:a16="http://schemas.microsoft.com/office/drawing/2014/main" id="{9DD28A69-5757-4965-934D-4D2BA7308015}"/>
               </a:ext>
             </a:extLst>
           </p:cNvPr>
@@ -5183,7 +5183,7 @@
           <p:cNvPr id="90" name="method-stage-2">
             <a:extLst xmlns:a="http://schemas.openxmlformats.org/drawingml/2006/main">
               <a:ext uri="{FF2B5EF4-FFF2-40B4-BE49-F238E27FC236}">
-                <a16:creationId xmlns:a16="http://schemas.microsoft.com/office/drawing/2014/main" id="{1EA0F405-F0AB-4EBA-A970-898E07B54C80}"/>
+                <a16:creationId xmlns:a16="http://schemas.microsoft.com/office/drawing/2014/main" id="{1886D1D1-E891-439D-B587-8A7F0492D73F}"/>
               </a:ext>
             </a:extLst>
           </p:cNvPr>
@@ -5215,7 +5215,7 @@
           <p:cNvPr id="91" name="stage-title-2">
             <a:extLst xmlns:a="http://schemas.openxmlformats.org/drawingml/2006/main">
               <a:ext uri="{FF2B5EF4-FFF2-40B4-BE49-F238E27FC236}">
-                <a16:creationId xmlns:a16="http://schemas.microsoft.com/office/drawing/2014/main" id="{FCF78BB6-5C4C-45D5-A8DD-11FF8E92C1AD}"/>
+                <a16:creationId xmlns:a16="http://schemas.microsoft.com/office/drawing/2014/main" id="{62D03C4D-C066-4A90-A6F2-5C5978C4C549}"/>
               </a:ext>
             </a:extLst>
           </p:cNvPr>
@@ -5283,7 +5283,7 @@
           <p:cNvPr id="92" name="stage-detail-2">
             <a:extLst xmlns:a="http://schemas.openxmlformats.org/drawingml/2006/main">
               <a:ext uri="{FF2B5EF4-FFF2-40B4-BE49-F238E27FC236}">
-                <a16:creationId xmlns:a16="http://schemas.microsoft.com/office/drawing/2014/main" id="{925CF19E-C6ED-40C8-BD3A-595C1347AA1A}"/>
+                <a16:creationId xmlns:a16="http://schemas.microsoft.com/office/drawing/2014/main" id="{231735A3-A311-4BF2-8F69-39223226439A}"/>
               </a:ext>
             </a:extLst>
           </p:cNvPr>
@@ -5351,7 +5351,7 @@
           <p:cNvPr id="93" name="method-stage-3">
             <a:extLst xmlns:a="http://schemas.openxmlformats.org/drawingml/2006/main">
               <a:ext uri="{FF2B5EF4-FFF2-40B4-BE49-F238E27FC236}">
-                <a16:creationId xmlns:a16="http://schemas.microsoft.com/office/drawing/2014/main" id="{1914B409-76EF-4AB9-A5DB-765125BC032A}"/>
+                <a16:creationId xmlns:a16="http://schemas.microsoft.com/office/drawing/2014/main" id="{576CB5E6-0085-4960-B398-DD6E20ACAF08}"/>
               </a:ext>
             </a:extLst>
           </p:cNvPr>
@@ -5383,7 +5383,7 @@
           <p:cNvPr id="94" name="stage-title-3">
             <a:extLst xmlns:a="http://schemas.openxmlformats.org/drawingml/2006/main">
               <a:ext uri="{FF2B5EF4-FFF2-40B4-BE49-F238E27FC236}">
-                <a16:creationId xmlns:a16="http://schemas.microsoft.com/office/drawing/2014/main" id="{E44C8CB9-D5B8-4E64-95AD-35630921244F}"/>
+                <a16:creationId xmlns:a16="http://schemas.microsoft.com/office/drawing/2014/main" id="{62AC3E68-C0A3-4AC4-8E28-D8CEA66DE249}"/>
               </a:ext>
             </a:extLst>
           </p:cNvPr>
@@ -5451,7 +5451,7 @@
           <p:cNvPr id="95" name="stage-detail-3">
             <a:extLst xmlns:a="http://schemas.openxmlformats.org/drawingml/2006/main">
               <a:ext uri="{FF2B5EF4-FFF2-40B4-BE49-F238E27FC236}">
-                <a16:creationId xmlns:a16="http://schemas.microsoft.com/office/drawing/2014/main" id="{F2F4E616-27AB-478A-A4FE-36798EFDD05E}"/>
+                <a16:creationId xmlns:a16="http://schemas.microsoft.com/office/drawing/2014/main" id="{F099FAB7-3845-4187-B07A-3C75CE14D61A}"/>
               </a:ext>
             </a:extLst>
           </p:cNvPr>
@@ -5519,7 +5519,7 @@
           <p:cNvPr id="96" name="stage-link-1">
             <a:extLst xmlns:a="http://schemas.openxmlformats.org/drawingml/2006/main">
               <a:ext uri="{FF2B5EF4-FFF2-40B4-BE49-F238E27FC236}">
-                <a16:creationId xmlns:a16="http://schemas.microsoft.com/office/drawing/2014/main" id="{68850C11-D182-4D6F-A0B1-7B73F23DDE3A}"/>
+                <a16:creationId xmlns:a16="http://schemas.microsoft.com/office/drawing/2014/main" id="{05C62A4D-AD22-4744-8019-A3E2588F3C20}"/>
               </a:ext>
             </a:extLst>
           </p:cNvPr>
@@ -5549,7 +5549,7 @@
           <p:cNvPr id="97" name="stage-link-2">
             <a:extLst xmlns:a="http://schemas.openxmlformats.org/drawingml/2006/main">
               <a:ext uri="{FF2B5EF4-FFF2-40B4-BE49-F238E27FC236}">
-                <a16:creationId xmlns:a16="http://schemas.microsoft.com/office/drawing/2014/main" id="{27C57051-FD8E-4F32-BAAC-A3515C12F4C6}"/>
+                <a16:creationId xmlns:a16="http://schemas.microsoft.com/office/drawing/2014/main" id="{E4410725-90F5-4E72-9D0B-914CD978F587}"/>
               </a:ext>
             </a:extLst>
           </p:cNvPr>
@@ -5579,7 +5579,7 @@
           <p:cNvPr id="98" name="final-score">
             <a:extLst xmlns:a="http://schemas.openxmlformats.org/drawingml/2006/main">
               <a:ext uri="{FF2B5EF4-FFF2-40B4-BE49-F238E27FC236}">
-                <a16:creationId xmlns:a16="http://schemas.microsoft.com/office/drawing/2014/main" id="{E69A17A1-6B33-40BF-891C-67471611A0C6}"/>
+                <a16:creationId xmlns:a16="http://schemas.microsoft.com/office/drawing/2014/main" id="{DDC2D6B6-5BDD-45BE-ACC5-AA419EFB1440}"/>
               </a:ext>
             </a:extLst>
           </p:cNvPr>
@@ -5647,7 +5647,7 @@
           <p:cNvPr id="99" name="Chart">
             <a:extLst xmlns:a="http://schemas.openxmlformats.org/drawingml/2006/main">
               <a:ext uri="{FF2B5EF4-FFF2-40B4-BE49-F238E27FC236}">
-                <a16:creationId xmlns:a16="http://schemas.microsoft.com/office/drawing/2014/main" id="{23755DEE-7491-4556-9CA9-0D04F0F608B9}"/>
+                <a16:creationId xmlns:a16="http://schemas.microsoft.com/office/drawing/2014/main" id="{B00160B1-BCA9-4706-9972-5A171C86D48B}"/>
               </a:ext>
             </a:extLst>
           </p:cNvPr>
@@ -5660,7 +5660,7 @@
         </p:xfrm>
         <a:graphic xmlns:a="http://schemas.openxmlformats.org/drawingml/2006/main">
           <a:graphicData uri="http://schemas.openxmlformats.org/drawingml/2006/chart">
-            <c:chart xmlns:r="http://schemas.openxmlformats.org/officeDocument/2006/relationships" xmlns:c="http://schemas.openxmlformats.org/drawingml/2006/chart" r:id="R6d508adc87e14cb0"/>
+            <c:chart xmlns:r="http://schemas.openxmlformats.org/officeDocument/2006/relationships" xmlns:c="http://schemas.openxmlformats.org/drawingml/2006/chart" r:id="R2a4ec528d7064de4"/>
           </a:graphicData>
         </a:graphic>
       </p:graphicFrame>
@@ -5669,7 +5669,7 @@
           <p:cNvPr id="100" name="future-title-0">
             <a:extLst xmlns:a="http://schemas.openxmlformats.org/drawingml/2006/main">
               <a:ext uri="{FF2B5EF4-FFF2-40B4-BE49-F238E27FC236}">
-                <a16:creationId xmlns:a16="http://schemas.microsoft.com/office/drawing/2014/main" id="{2C219130-1900-4C70-B5E2-B87A300E43B5}"/>
+                <a16:creationId xmlns:a16="http://schemas.microsoft.com/office/drawing/2014/main" id="{6910094B-CD6A-45F7-AE7D-46B591227A5C}"/>
               </a:ext>
             </a:extLst>
           </p:cNvPr>
@@ -5737,7 +5737,7 @@
           <p:cNvPr id="101" name="future-detail-0">
             <a:extLst xmlns:a="http://schemas.openxmlformats.org/drawingml/2006/main">
               <a:ext uri="{FF2B5EF4-FFF2-40B4-BE49-F238E27FC236}">
-                <a16:creationId xmlns:a16="http://schemas.microsoft.com/office/drawing/2014/main" id="{F9B5B244-068E-40B3-A3F7-58345726ACDB}"/>
+                <a16:creationId xmlns:a16="http://schemas.microsoft.com/office/drawing/2014/main" id="{391EB6EA-BE0B-4334-8535-4D589319A9EC}"/>
               </a:ext>
             </a:extLst>
           </p:cNvPr>
@@ -5851,7 +5851,7 @@
           <p:cNvPr id="102" name="future-title-1">
             <a:extLst xmlns:a="http://schemas.openxmlformats.org/drawingml/2006/main">
               <a:ext uri="{FF2B5EF4-FFF2-40B4-BE49-F238E27FC236}">
-                <a16:creationId xmlns:a16="http://schemas.microsoft.com/office/drawing/2014/main" id="{F6FB739A-846C-4993-9115-A69D3825AE48}"/>
+                <a16:creationId xmlns:a16="http://schemas.microsoft.com/office/drawing/2014/main" id="{0241399B-EAC0-40C9-B152-AB7C9EF74A38}"/>
               </a:ext>
             </a:extLst>
           </p:cNvPr>
@@ -5919,7 +5919,7 @@
           <p:cNvPr id="103" name="future-detail-1">
             <a:extLst xmlns:a="http://schemas.openxmlformats.org/drawingml/2006/main">
               <a:ext uri="{FF2B5EF4-FFF2-40B4-BE49-F238E27FC236}">
-                <a16:creationId xmlns:a16="http://schemas.microsoft.com/office/drawing/2014/main" id="{FC85464C-4265-449B-85C8-E8ABD11C90C0}"/>
+                <a16:creationId xmlns:a16="http://schemas.microsoft.com/office/drawing/2014/main" id="{92073676-9790-413A-8987-C3F8F5DADBC5}"/>
               </a:ext>
             </a:extLst>
           </p:cNvPr>
@@ -6033,7 +6033,7 @@
           <p:cNvPr id="104" name="future-title-2">
             <a:extLst xmlns:a="http://schemas.openxmlformats.org/drawingml/2006/main">
               <a:ext uri="{FF2B5EF4-FFF2-40B4-BE49-F238E27FC236}">
-                <a16:creationId xmlns:a16="http://schemas.microsoft.com/office/drawing/2014/main" id="{91D69BD4-9CBF-4A11-BBD2-26B1859C4B1F}"/>
+                <a16:creationId xmlns:a16="http://schemas.microsoft.com/office/drawing/2014/main" id="{2F005EE1-3EE2-4115-81DD-E25D62DBBD26}"/>
               </a:ext>
             </a:extLst>
           </p:cNvPr>
@@ -6101,7 +6101,7 @@
           <p:cNvPr id="105" name="future-detail-2">
             <a:extLst xmlns:a="http://schemas.openxmlformats.org/drawingml/2006/main">
               <a:ext uri="{FF2B5EF4-FFF2-40B4-BE49-F238E27FC236}">
-                <a16:creationId xmlns:a16="http://schemas.microsoft.com/office/drawing/2014/main" id="{94758E46-E630-4EFF-9F8A-3F78A7C2E200}"/>
+                <a16:creationId xmlns:a16="http://schemas.microsoft.com/office/drawing/2014/main" id="{0C1CEC61-8E78-423D-A884-48D914D23F0E}"/>
               </a:ext>
             </a:extLst>
           </p:cNvPr>
@@ -6215,7 +6215,7 @@
           <p:cNvPr id="106" name="future-title-3">
             <a:extLst xmlns:a="http://schemas.openxmlformats.org/drawingml/2006/main">
               <a:ext uri="{FF2B5EF4-FFF2-40B4-BE49-F238E27FC236}">
-                <a16:creationId xmlns:a16="http://schemas.microsoft.com/office/drawing/2014/main" id="{A8DEDFF3-C2DB-4DD3-969F-7E371D8AF18E}"/>
+                <a16:creationId xmlns:a16="http://schemas.microsoft.com/office/drawing/2014/main" id="{29F9EA18-A187-4966-B5A2-94BE82783DB2}"/>
               </a:ext>
             </a:extLst>
           </p:cNvPr>
@@ -6283,7 +6283,7 @@
           <p:cNvPr id="107" name="future-detail-3">
             <a:extLst xmlns:a="http://schemas.openxmlformats.org/drawingml/2006/main">
               <a:ext uri="{FF2B5EF4-FFF2-40B4-BE49-F238E27FC236}">
-                <a16:creationId xmlns:a16="http://schemas.microsoft.com/office/drawing/2014/main" id="{B8F0AE7C-F8C1-4701-BEB5-897B9E9F04D8}"/>
+                <a16:creationId xmlns:a16="http://schemas.microsoft.com/office/drawing/2014/main" id="{056A12FD-E1FE-454A-8352-DD0501431349}"/>
               </a:ext>
             </a:extLst>
           </p:cNvPr>
@@ -6397,7 +6397,7 @@
           <p:cNvPr id="108" name="evidence-boundary">
             <a:extLst xmlns:a="http://schemas.openxmlformats.org/drawingml/2006/main">
               <a:ext uri="{FF2B5EF4-FFF2-40B4-BE49-F238E27FC236}">
-                <a16:creationId xmlns:a16="http://schemas.microsoft.com/office/drawing/2014/main" id="{55C5DEDF-AF1D-4A48-9CDB-9922BFBD6907}"/>
+                <a16:creationId xmlns:a16="http://schemas.microsoft.com/office/drawing/2014/main" id="{5F83230C-C779-4554-ACA3-B7D6CDB7F8A4}"/>
               </a:ext>
             </a:extLst>
           </p:cNvPr>

</xml_diff>

<commit_message>
Clarify LLM engineering study framing and expand abstract
</commit_message>
<xml_diff>
--- a/docs/materials/ai4e-poster.pptx
+++ b/docs/materials/ai4e-poster.pptx
@@ -2,13 +2,13 @@
 <file path=ppt/presentation.xml><?xml version="1.0" encoding="utf-8"?>
 <p:presentation xmlns:p="http://schemas.openxmlformats.org/presentationml/2006/main">
   <p:sldMasterIdLst>
-    <p:sldMasterId xmlns:r="http://schemas.openxmlformats.org/officeDocument/2006/relationships" id="2147483648" r:id="R4a3ac1f197e24f19"/>
+    <p:sldMasterId xmlns:r="http://schemas.openxmlformats.org/officeDocument/2006/relationships" id="2147483648" r:id="R0d41763854bb45b3"/>
   </p:sldMasterIdLst>
   <p:notesMasterIdLst>
-    <p:notesMasterId xmlns:r="http://schemas.openxmlformats.org/officeDocument/2006/relationships" r:id="R052fc592385544c6"/>
+    <p:notesMasterId xmlns:r="http://schemas.openxmlformats.org/officeDocument/2006/relationships" r:id="R75b8098073a046fb"/>
   </p:notesMasterIdLst>
   <p:sldIdLst>
-    <p:sldId xmlns:r="http://schemas.openxmlformats.org/officeDocument/2006/relationships" id="256" r:id="Re62d67e5fa1e4151"/>
+    <p:sldId xmlns:r="http://schemas.openxmlformats.org/officeDocument/2006/relationships" id="256" r:id="R376c77529b924e15"/>
   </p:sldIdLst>
   <p:sldSz cx="21599525" cy="32399288"/>
   <p:notesSz cx="6858000" cy="9144000"/>
@@ -546,7 +546,7 @@
           <a:lstStyle xmlns:a="http://schemas.openxmlformats.org/drawingml/2006/main"/>
           <a:p xmlns:a="http://schemas.openxmlformats.org/drawingml/2006/main">
             <a:r>
-              <a:t>内容来源：OpenTrust_工程研究论文_中文正式稿.pdf（2026-10-15），main.tex，附录与冻结结果。作者：谢宇宸、任沛然（通讯作者），同济大学。主结果为有限合同下的合格数；672 条路线共享起点，不是独立样本。CPU 基线资源不匹配。图表数据为论文报告的冻结结果；未进行新增模型调用。右上保留工况分析经主代理独立读取 final_results.json 的 final_held[passed] 核对并由数据代理复核：无反馈同配置51、跨配置46，有反馈同配置68、跨配置70，分母均96；指8个保留工况全部通过，与主图16工况完整合同合格数分开。参考文献：[1] Madaan et al., Self-Refine: Iterative Refinement with Self-Feedback, NeurIPS 2023, https://arxiv.org/abs/2303.17651 。[2] https://pandapower.readthedocs.io/en/latest/networks.html 。原模板品牌图像按用户指定保留。</a:t>
+              <a:t>研究定位：通过 API 调用现有大语言模型，为配电与供水网络提出受设备目录、动作权限与量化阈值约束的控制方案。在共享初始方案、所选开发测试与一次修订机会下，比较候选执行反馈和额外审查的增量。CPU 执行方案并按冻结的物理判据评分。贡献定位为评估设计、执行语义核验与有限合同内的实证分析。当前论文题目：大语言模型辅助工程设计中的执行反馈与审查——配电与供水网络的对照研究。内容来源：当前 main.tex、附录、冻结方案与评分记录（2026-10-15）。作者：谢宇宸、任沛然（通讯作者），同济大学。672 条路线共享 96 个起点，不是独立样本。CPU 参照预算与重置权限不同。右上保留工况合格数为无反馈同配置51、跨配置46，有反馈同配置68、跨配置70，分母均96；指8个保留工况全部通过，与主图16工况完整合同合格数分开。4个动作干预案例均为事后局部分析，不构成总体因果证明。参考文献：[1] Madaan et al., Self-Refine: Iterative Refinement with Self-Feedback, NeurIPS 2023, https://arxiv.org/abs/2303.17651 。[2] https://pandapower.readthedocs.io/en/latest/networks.html 。</a:t>
             </a:r>
             <a:endParaRPr/>
           </a:p>
@@ -621,7 +621,7 @@
   </p:cSld>
   <p:clrMap bg1="lt1" tx1="dk1" bg2="lt2" tx2="dk2" accent1="accent1" accent2="accent2" accent3="accent3" accent4="accent4" accent5="accent5" accent6="accent6" hlink="hlink" folHlink="folHlink"/>
   <p:sldLayoutIdLst>
-    <p:sldLayoutId xmlns:r="http://schemas.openxmlformats.org/officeDocument/2006/relationships" id="2147483649" r:id="Rd406ceef34f2439b"/>
+    <p:sldLayoutId xmlns:r="http://schemas.openxmlformats.org/officeDocument/2006/relationships" id="2147483649" r:id="R0196198c015c4b6a"/>
   </p:sldLayoutIdLst>
   <p:txStyles>
     <p:titleStyle>
@@ -1464,7 +1464,7 @@
           <p:cNvPr id="52" name="图片 51">
             <a:extLst xmlns:a="http://schemas.openxmlformats.org/drawingml/2006/main">
               <a:ext uri="{FF2B5EF4-FFF2-40B4-BE49-F238E27FC236}">
-                <a16:creationId xmlns:a16="http://schemas.microsoft.com/office/drawing/2014/main" id="{AF36A405-883D-4B91-986D-65CDF7C271D9}"/>
+                <a16:creationId xmlns:a16="http://schemas.microsoft.com/office/drawing/2014/main" id="{56DD83F9-8C76-47A0-935A-4001AC35141E}"/>
               </a:ext>
             </a:extLst>
           </p:cNvPr>
@@ -1474,7 +1474,7 @@
           <p:nvPr/>
         </p:nvPicPr>
         <p:blipFill>
-          <a:blip xmlns:r="http://schemas.openxmlformats.org/officeDocument/2006/relationships" xmlns:a="http://schemas.openxmlformats.org/drawingml/2006/main" r:embed="Raf1ff40ff9da4c02"/>
+          <a:blip xmlns:r="http://schemas.openxmlformats.org/officeDocument/2006/relationships" xmlns:a="http://schemas.openxmlformats.org/drawingml/2006/main" r:embed="R46055ceaf34b4031"/>
           <a:srcRect xmlns:a="http://schemas.openxmlformats.org/drawingml/2006/main" l="0" t="1750" r="0" b="1750"/>
           <a:stretch xmlns:a="http://schemas.openxmlformats.org/drawingml/2006/main">
             <a:fillRect l="0" t="0" r="0" b="0"/>
@@ -1822,7 +1822,7 @@
           <p:cNvPr id="59" name="图片 58">
             <a:extLst xmlns:a="http://schemas.openxmlformats.org/drawingml/2006/main">
               <a:ext uri="{FF2B5EF4-FFF2-40B4-BE49-F238E27FC236}">
-                <a16:creationId xmlns:a16="http://schemas.microsoft.com/office/drawing/2014/main" id="{F98ED320-CD17-494A-A2D5-82E3138DC901}"/>
+                <a16:creationId xmlns:a16="http://schemas.microsoft.com/office/drawing/2014/main" id="{1D091980-4154-4788-B292-1C1AA299B782}"/>
               </a:ext>
             </a:extLst>
           </p:cNvPr>
@@ -1832,7 +1832,7 @@
           <p:nvPr/>
         </p:nvPicPr>
         <p:blipFill>
-          <a:blip xmlns:r="http://schemas.openxmlformats.org/officeDocument/2006/relationships" xmlns:a="http://schemas.openxmlformats.org/drawingml/2006/main" r:embed="Rb62d0136c85145f7"/>
+          <a:blip xmlns:r="http://schemas.openxmlformats.org/officeDocument/2006/relationships" xmlns:a="http://schemas.openxmlformats.org/drawingml/2006/main" r:embed="Rac83efa7c1b247f0"/>
           <a:srcRect xmlns:a="http://schemas.openxmlformats.org/drawingml/2006/main" l="500" t="23500" r="500" b="23500"/>
           <a:stretch xmlns:a="http://schemas.openxmlformats.org/drawingml/2006/main"/>
         </p:blipFill>
@@ -1851,7 +1851,7 @@
           <p:cNvPr id="60" name="图片 59">
             <a:extLst xmlns:a="http://schemas.openxmlformats.org/drawingml/2006/main">
               <a:ext uri="{FF2B5EF4-FFF2-40B4-BE49-F238E27FC236}">
-                <a16:creationId xmlns:a16="http://schemas.microsoft.com/office/drawing/2014/main" id="{5D859052-A753-4CA7-AD94-15060CEBABE0}"/>
+                <a16:creationId xmlns:a16="http://schemas.microsoft.com/office/drawing/2014/main" id="{DF6EF45C-6462-498A-828E-61CB0DF5CA47}"/>
               </a:ext>
             </a:extLst>
           </p:cNvPr>
@@ -1861,7 +1861,7 @@
           <p:nvPr/>
         </p:nvPicPr>
         <p:blipFill>
-          <a:blip xmlns:r="http://schemas.openxmlformats.org/officeDocument/2006/relationships" xmlns:a="http://schemas.openxmlformats.org/drawingml/2006/main" r:embed="Rd57b7806b20d43de"/>
+          <a:blip xmlns:r="http://schemas.openxmlformats.org/officeDocument/2006/relationships" xmlns:a="http://schemas.openxmlformats.org/drawingml/2006/main" r:embed="Re6571ac37c8a4577"/>
           <a:stretch xmlns:a="http://schemas.openxmlformats.org/drawingml/2006/main"/>
         </p:blipFill>
         <p:spPr>
@@ -2269,7 +2269,7 @@
                 <a:ea typeface="Microsoft YaHei"/>
                 <a:cs typeface="Microsoft YaHei"/>
               </a:rPr>
-              <a:t>01  工程评估创新与实证增量</a:t>
+              <a:t>01  研究问题与评估贡献</a:t>
             </a:r>
           </a:p>
         </p:txBody>
@@ -2378,7 +2378,7 @@
                 <a:ea typeface="Microsoft YaHei"/>
                 <a:cs typeface="Microsoft YaHei"/>
               </a:rPr>
-              <a:t>核对批准动作、实际执行与最终约束。</a:t>
+              <a:t>调用现有 LLM，评估受约束设备控制设计。</a:t>
             </a:r>
           </a:p>
         </p:txBody>
@@ -2450,7 +2450,7 @@
                 <a:ea typeface="Microsoft YaHei"/>
                 <a:cs typeface="Microsoft YaHei"/>
               </a:rPr>
-              <a:t>02  模型参与的设计流程</a:t>
+              <a:t>02  模型 API 调用与 CPU 评分</a:t>
             </a:r>
           </a:p>
         </p:txBody>
@@ -3296,7 +3296,7 @@
           <p:cNvPr id="86" name="表格 85">
             <a:extLst xmlns:a="http://schemas.openxmlformats.org/drawingml/2006/main">
               <a:ext uri="{FF2B5EF4-FFF2-40B4-BE49-F238E27FC236}">
-                <a16:creationId xmlns:a16="http://schemas.microsoft.com/office/drawing/2014/main" id="{F3698706-6CA7-4159-95D9-F2DC43FB3BE4}"/>
+                <a16:creationId xmlns:a16="http://schemas.microsoft.com/office/drawing/2014/main" id="{D45CBDAE-52CE-48D1-9EBF-F1A3264FD7AC}"/>
               </a:ext>
             </a:extLst>
           </p:cNvPr>
@@ -4672,7 +4672,7 @@
           <p:cNvPr id="87" name="contribution-title-0">
             <a:extLst xmlns:a="http://schemas.openxmlformats.org/drawingml/2006/main">
               <a:ext uri="{FF2B5EF4-FFF2-40B4-BE49-F238E27FC236}">
-                <a16:creationId xmlns:a16="http://schemas.microsoft.com/office/drawing/2014/main" id="{388BBD85-BFEC-45D7-9D76-B8DEF2651F03}"/>
+                <a16:creationId xmlns:a16="http://schemas.microsoft.com/office/drawing/2014/main" id="{75DFCE19-550F-4723-9F41-0C19C4F7F3E2}"/>
               </a:ext>
             </a:extLst>
           </p:cNvPr>
@@ -4734,7 +4734,7 @@
                 <a:ea typeface="Microsoft YaHei"/>
                 <a:cs typeface="Microsoft YaHei"/>
               </a:rPr>
-              <a:t>1  可执行合同与动作核验</a:t>
+              <a:t>1  固定合同与动作核验</a:t>
             </a:r>
           </a:p>
         </p:txBody>
@@ -4744,7 +4744,7 @@
           <p:cNvPr id="88" name="contribution-detail-0">
             <a:extLst xmlns:a="http://schemas.openxmlformats.org/drawingml/2006/main">
               <a:ext uri="{FF2B5EF4-FFF2-40B4-BE49-F238E27FC236}">
-                <a16:creationId xmlns:a16="http://schemas.microsoft.com/office/drawing/2014/main" id="{4E6C6348-261D-429B-90F6-E8FED6C67F3E}"/>
+                <a16:creationId xmlns:a16="http://schemas.microsoft.com/office/drawing/2014/main" id="{C78B3196-B818-43EA-82FB-314A3D06397D}"/>
               </a:ext>
             </a:extLst>
           </p:cNvPr>
@@ -4816,7 +4816,7 @@
           <p:cNvPr id="89" name="contribution-title-1">
             <a:extLst xmlns:a="http://schemas.openxmlformats.org/drawingml/2006/main">
               <a:ext uri="{FF2B5EF4-FFF2-40B4-BE49-F238E27FC236}">
-                <a16:creationId xmlns:a16="http://schemas.microsoft.com/office/drawing/2014/main" id="{B4F09511-BE21-4108-A12D-568FE56076CF}"/>
+                <a16:creationId xmlns:a16="http://schemas.microsoft.com/office/drawing/2014/main" id="{D036045A-1E89-46D4-A91B-07690829791E}"/>
               </a:ext>
             </a:extLst>
           </p:cNvPr>
@@ -4878,7 +4878,7 @@
                 <a:ea typeface="Microsoft YaHei"/>
                 <a:cs typeface="Microsoft YaHei"/>
               </a:rPr>
-              <a:t>2  同起点因素对照</a:t>
+              <a:t>2  反馈与额外审查的对照</a:t>
             </a:r>
           </a:p>
         </p:txBody>
@@ -4888,7 +4888,7 @@
           <p:cNvPr id="90" name="contribution-detail-1">
             <a:extLst xmlns:a="http://schemas.openxmlformats.org/drawingml/2006/main">
               <a:ext uri="{FF2B5EF4-FFF2-40B4-BE49-F238E27FC236}">
-                <a16:creationId xmlns:a16="http://schemas.microsoft.com/office/drawing/2014/main" id="{8BA03853-1829-4801-AC4C-2D2710119B61}"/>
+                <a16:creationId xmlns:a16="http://schemas.microsoft.com/office/drawing/2014/main" id="{6F5C61CE-DE93-4B9A-A631-376EBEADA4F2}"/>
               </a:ext>
             </a:extLst>
           </p:cNvPr>
@@ -4960,7 +4960,7 @@
           <p:cNvPr id="91" name="contribution-title-2">
             <a:extLst xmlns:a="http://schemas.openxmlformats.org/drawingml/2006/main">
               <a:ext uri="{FF2B5EF4-FFF2-40B4-BE49-F238E27FC236}">
-                <a16:creationId xmlns:a16="http://schemas.microsoft.com/office/drawing/2014/main" id="{BAA74E4E-8DB3-4AD7-824C-7A80812F7F89}"/>
+                <a16:creationId xmlns:a16="http://schemas.microsoft.com/office/drawing/2014/main" id="{F76FC0F0-9571-4C88-B617-598CAA23DA0B}"/>
               </a:ext>
             </a:extLst>
           </p:cNvPr>
@@ -5032,7 +5032,7 @@
           <p:cNvPr id="92" name="contribution-detail-2">
             <a:extLst xmlns:a="http://schemas.openxmlformats.org/drawingml/2006/main">
               <a:ext uri="{FF2B5EF4-FFF2-40B4-BE49-F238E27FC236}">
-                <a16:creationId xmlns:a16="http://schemas.microsoft.com/office/drawing/2014/main" id="{EB6D9FA8-D8FE-47B2-8AEF-91A73F329974}"/>
+                <a16:creationId xmlns:a16="http://schemas.microsoft.com/office/drawing/2014/main" id="{A5F6EF44-6C80-42C0-AEAE-D14D9AD947EC}"/>
               </a:ext>
             </a:extLst>
           </p:cNvPr>
@@ -5104,7 +5104,7 @@
           <p:cNvPr id="93" name="method-stage-1">
             <a:extLst xmlns:a="http://schemas.openxmlformats.org/drawingml/2006/main">
               <a:ext uri="{FF2B5EF4-FFF2-40B4-BE49-F238E27FC236}">
-                <a16:creationId xmlns:a16="http://schemas.microsoft.com/office/drawing/2014/main" id="{15C7F19C-51A3-4AFF-9649-641F09ADB098}"/>
+                <a16:creationId xmlns:a16="http://schemas.microsoft.com/office/drawing/2014/main" id="{D42F80CF-A833-49D9-BF68-A80BC6B0564B}"/>
               </a:ext>
             </a:extLst>
           </p:cNvPr>
@@ -5136,7 +5136,7 @@
           <p:cNvPr id="94" name="stage-title-1">
             <a:extLst xmlns:a="http://schemas.openxmlformats.org/drawingml/2006/main">
               <a:ext uri="{FF2B5EF4-FFF2-40B4-BE49-F238E27FC236}">
-                <a16:creationId xmlns:a16="http://schemas.microsoft.com/office/drawing/2014/main" id="{8731EF27-DA5B-4AD3-8EDC-04035D7676CB}"/>
+                <a16:creationId xmlns:a16="http://schemas.microsoft.com/office/drawing/2014/main" id="{19834F89-C7A3-43AA-B415-C4D125A7253C}"/>
               </a:ext>
             </a:extLst>
           </p:cNvPr>
@@ -5198,7 +5198,7 @@
                 <a:ea typeface="Microsoft YaHei"/>
                 <a:cs typeface="Microsoft YaHei"/>
               </a:rPr>
-              <a:t>模型生成</a:t>
+              <a:t>LLM 生成</a:t>
             </a:r>
           </a:p>
         </p:txBody>
@@ -5208,7 +5208,7 @@
           <p:cNvPr id="95" name="stage-detail-1">
             <a:extLst xmlns:a="http://schemas.openxmlformats.org/drawingml/2006/main">
               <a:ext uri="{FF2B5EF4-FFF2-40B4-BE49-F238E27FC236}">
-                <a16:creationId xmlns:a16="http://schemas.microsoft.com/office/drawing/2014/main" id="{35DF7EED-4227-4DC1-B6DD-340BF6AF4A61}"/>
+                <a16:creationId xmlns:a16="http://schemas.microsoft.com/office/drawing/2014/main" id="{429AFE6F-0237-418C-B5BF-4F8C14A26762}"/>
               </a:ext>
             </a:extLst>
           </p:cNvPr>
@@ -5280,7 +5280,7 @@
           <p:cNvPr id="96" name="method-stage-2">
             <a:extLst xmlns:a="http://schemas.openxmlformats.org/drawingml/2006/main">
               <a:ext uri="{FF2B5EF4-FFF2-40B4-BE49-F238E27FC236}">
-                <a16:creationId xmlns:a16="http://schemas.microsoft.com/office/drawing/2014/main" id="{F1031470-FA8E-4196-BC97-EC82D7C07AF4}"/>
+                <a16:creationId xmlns:a16="http://schemas.microsoft.com/office/drawing/2014/main" id="{A0869926-B497-449F-B809-801FEFD0BE25}"/>
               </a:ext>
             </a:extLst>
           </p:cNvPr>
@@ -5312,7 +5312,7 @@
           <p:cNvPr id="97" name="stage-title-2">
             <a:extLst xmlns:a="http://schemas.openxmlformats.org/drawingml/2006/main">
               <a:ext uri="{FF2B5EF4-FFF2-40B4-BE49-F238E27FC236}">
-                <a16:creationId xmlns:a16="http://schemas.microsoft.com/office/drawing/2014/main" id="{0E6E35D5-ECF3-4578-9C1C-728499AA8ADD}"/>
+                <a16:creationId xmlns:a16="http://schemas.microsoft.com/office/drawing/2014/main" id="{5E996C7B-0A5E-48FF-9BA8-2D3D84BF23D4}"/>
               </a:ext>
             </a:extLst>
           </p:cNvPr>
@@ -5374,7 +5374,7 @@
                 <a:ea typeface="Microsoft YaHei"/>
                 <a:cs typeface="Microsoft YaHei"/>
               </a:rPr>
-              <a:t>候选执行</a:t>
+              <a:t>CPU 执行</a:t>
             </a:r>
           </a:p>
         </p:txBody>
@@ -5384,7 +5384,7 @@
           <p:cNvPr id="98" name="stage-detail-2">
             <a:extLst xmlns:a="http://schemas.openxmlformats.org/drawingml/2006/main">
               <a:ext uri="{FF2B5EF4-FFF2-40B4-BE49-F238E27FC236}">
-                <a16:creationId xmlns:a16="http://schemas.microsoft.com/office/drawing/2014/main" id="{DE9A7F97-F791-4853-B96E-92CF6E98047F}"/>
+                <a16:creationId xmlns:a16="http://schemas.microsoft.com/office/drawing/2014/main" id="{CCB9DFA2-A501-4BE6-90A3-B281B0DDA33F}"/>
               </a:ext>
             </a:extLst>
           </p:cNvPr>
@@ -5456,7 +5456,7 @@
           <p:cNvPr id="99" name="method-stage-3">
             <a:extLst xmlns:a="http://schemas.openxmlformats.org/drawingml/2006/main">
               <a:ext uri="{FF2B5EF4-FFF2-40B4-BE49-F238E27FC236}">
-                <a16:creationId xmlns:a16="http://schemas.microsoft.com/office/drawing/2014/main" id="{58D4860B-20F3-4015-B3F2-E0AF337A275C}"/>
+                <a16:creationId xmlns:a16="http://schemas.microsoft.com/office/drawing/2014/main" id="{69906F0B-B859-43E5-B9BC-47EE36B5169C}"/>
               </a:ext>
             </a:extLst>
           </p:cNvPr>
@@ -5488,7 +5488,7 @@
           <p:cNvPr id="100" name="stage-title-3">
             <a:extLst xmlns:a="http://schemas.openxmlformats.org/drawingml/2006/main">
               <a:ext uri="{FF2B5EF4-FFF2-40B4-BE49-F238E27FC236}">
-                <a16:creationId xmlns:a16="http://schemas.microsoft.com/office/drawing/2014/main" id="{DDA2C211-FADE-4217-B022-DEF64318B224}"/>
+                <a16:creationId xmlns:a16="http://schemas.microsoft.com/office/drawing/2014/main" id="{DF470BDB-EF1E-4220-BE3F-664D30247E46}"/>
               </a:ext>
             </a:extLst>
           </p:cNvPr>
@@ -5550,7 +5550,7 @@
                 <a:ea typeface="Microsoft YaHei"/>
                 <a:cs typeface="Microsoft YaHei"/>
               </a:rPr>
-              <a:t>模型审查</a:t>
+              <a:t>LLM 审查</a:t>
             </a:r>
           </a:p>
         </p:txBody>
@@ -5560,7 +5560,7 @@
           <p:cNvPr id="101" name="stage-detail-3">
             <a:extLst xmlns:a="http://schemas.openxmlformats.org/drawingml/2006/main">
               <a:ext uri="{FF2B5EF4-FFF2-40B4-BE49-F238E27FC236}">
-                <a16:creationId xmlns:a16="http://schemas.microsoft.com/office/drawing/2014/main" id="{12CB7E01-E5DC-44A1-B6D5-C42EA5E9821B}"/>
+                <a16:creationId xmlns:a16="http://schemas.microsoft.com/office/drawing/2014/main" id="{CB7A56B0-7C68-4C86-9551-744EDA444437}"/>
               </a:ext>
             </a:extLst>
           </p:cNvPr>
@@ -5632,7 +5632,7 @@
           <p:cNvPr id="102" name="method-stage-4">
             <a:extLst xmlns:a="http://schemas.openxmlformats.org/drawingml/2006/main">
               <a:ext uri="{FF2B5EF4-FFF2-40B4-BE49-F238E27FC236}">
-                <a16:creationId xmlns:a16="http://schemas.microsoft.com/office/drawing/2014/main" id="{55413811-1BFC-4AC1-B737-F9A21FCC7990}"/>
+                <a16:creationId xmlns:a16="http://schemas.microsoft.com/office/drawing/2014/main" id="{2FD6C687-ECF6-474D-BC98-7E24F94606DE}"/>
               </a:ext>
             </a:extLst>
           </p:cNvPr>
@@ -5664,7 +5664,7 @@
           <p:cNvPr id="103" name="stage-title-4">
             <a:extLst xmlns:a="http://schemas.openxmlformats.org/drawingml/2006/main">
               <a:ext uri="{FF2B5EF4-FFF2-40B4-BE49-F238E27FC236}">
-                <a16:creationId xmlns:a16="http://schemas.microsoft.com/office/drawing/2014/main" id="{800F7A41-A3E2-4B67-90DE-4F2DCDC6AF6E}"/>
+                <a16:creationId xmlns:a16="http://schemas.microsoft.com/office/drawing/2014/main" id="{E08634AB-CE13-4B8A-8EC9-23CE2782AB9F}"/>
               </a:ext>
             </a:extLst>
           </p:cNvPr>
@@ -5726,7 +5726,7 @@
                 <a:ea typeface="Microsoft YaHei"/>
                 <a:cs typeface="Microsoft YaHei"/>
               </a:rPr>
-              <a:t>模型修订</a:t>
+              <a:t>LLM 修订</a:t>
             </a:r>
           </a:p>
         </p:txBody>
@@ -5736,7 +5736,7 @@
           <p:cNvPr id="104" name="stage-detail-4">
             <a:extLst xmlns:a="http://schemas.openxmlformats.org/drawingml/2006/main">
               <a:ext uri="{FF2B5EF4-FFF2-40B4-BE49-F238E27FC236}">
-                <a16:creationId xmlns:a16="http://schemas.microsoft.com/office/drawing/2014/main" id="{9853946B-7B10-42C8-B30B-82008DAB757F}"/>
+                <a16:creationId xmlns:a16="http://schemas.microsoft.com/office/drawing/2014/main" id="{E9B7763A-6F8E-4348-8FCC-ACEB34DE18DB}"/>
               </a:ext>
             </a:extLst>
           </p:cNvPr>
@@ -5808,7 +5808,7 @@
           <p:cNvPr id="105" name="stage-link-1">
             <a:extLst xmlns:a="http://schemas.openxmlformats.org/drawingml/2006/main">
               <a:ext uri="{FF2B5EF4-FFF2-40B4-BE49-F238E27FC236}">
-                <a16:creationId xmlns:a16="http://schemas.microsoft.com/office/drawing/2014/main" id="{CF717FE9-696F-4027-B6F4-8DDC3D302DCA}"/>
+                <a16:creationId xmlns:a16="http://schemas.microsoft.com/office/drawing/2014/main" id="{05FD77B9-6935-4867-B7B0-473235ADCF3E}"/>
               </a:ext>
             </a:extLst>
           </p:cNvPr>
@@ -5838,7 +5838,7 @@
           <p:cNvPr id="106" name="stage-link-2">
             <a:extLst xmlns:a="http://schemas.openxmlformats.org/drawingml/2006/main">
               <a:ext uri="{FF2B5EF4-FFF2-40B4-BE49-F238E27FC236}">
-                <a16:creationId xmlns:a16="http://schemas.microsoft.com/office/drawing/2014/main" id="{29C290D2-13A8-4C82-BE20-D2C800863096}"/>
+                <a16:creationId xmlns:a16="http://schemas.microsoft.com/office/drawing/2014/main" id="{CDF3AEA4-490B-4A16-9636-1203950F2439}"/>
               </a:ext>
             </a:extLst>
           </p:cNvPr>
@@ -5868,7 +5868,7 @@
           <p:cNvPr id="107" name="stage-link-3">
             <a:extLst xmlns:a="http://schemas.openxmlformats.org/drawingml/2006/main">
               <a:ext uri="{FF2B5EF4-FFF2-40B4-BE49-F238E27FC236}">
-                <a16:creationId xmlns:a16="http://schemas.microsoft.com/office/drawing/2014/main" id="{001BFC30-3434-4B28-A763-B1C577F8541B}"/>
+                <a16:creationId xmlns:a16="http://schemas.microsoft.com/office/drawing/2014/main" id="{C952E789-EE8B-41F1-804E-EB531B935C42}"/>
               </a:ext>
             </a:extLst>
           </p:cNvPr>
@@ -5898,7 +5898,7 @@
           <p:cNvPr id="108" name="final-score">
             <a:extLst xmlns:a="http://schemas.openxmlformats.org/drawingml/2006/main">
               <a:ext uri="{FF2B5EF4-FFF2-40B4-BE49-F238E27FC236}">
-                <a16:creationId xmlns:a16="http://schemas.microsoft.com/office/drawing/2014/main" id="{FCF94190-7E01-4D75-8501-AD2735839FD7}"/>
+                <a16:creationId xmlns:a16="http://schemas.microsoft.com/office/drawing/2014/main" id="{4B0A0F7A-51F5-41E5-8BB3-4C453D6E7664}"/>
               </a:ext>
             </a:extLst>
           </p:cNvPr>
@@ -5960,7 +5960,7 @@
                 <a:ea typeface="Microsoft YaHei"/>
                 <a:cs typeface="Microsoft YaHei"/>
               </a:rPr>
-              <a:t>冻结后统一评分：8 开发 + 8 保留工况</a:t>
+              <a:t>冻结后 CPU 评分：8 开发 + 8 保留工况</a:t>
             </a:r>
           </a:p>
         </p:txBody>
@@ -5970,7 +5970,7 @@
           <p:cNvPr id="109" name="rural-case">
             <a:extLst xmlns:a="http://schemas.openxmlformats.org/drawingml/2006/main">
               <a:ext uri="{FF2B5EF4-FFF2-40B4-BE49-F238E27FC236}">
-                <a16:creationId xmlns:a16="http://schemas.microsoft.com/office/drawing/2014/main" id="{A20FDA3E-7920-4BC1-A7E4-20120D74794F}"/>
+                <a16:creationId xmlns:a16="http://schemas.microsoft.com/office/drawing/2014/main" id="{BDB55775-14A9-4771-9E60-762592D3D211}"/>
               </a:ext>
             </a:extLst>
           </p:cNvPr>
@@ -6042,7 +6042,7 @@
           <p:cNvPr id="110" name="rural-detail">
             <a:extLst xmlns:a="http://schemas.openxmlformats.org/drawingml/2006/main">
               <a:ext uri="{FF2B5EF4-FFF2-40B4-BE49-F238E27FC236}">
-                <a16:creationId xmlns:a16="http://schemas.microsoft.com/office/drawing/2014/main" id="{C20A0F3B-2DDC-4D20-9C24-0930773761D3}"/>
+                <a16:creationId xmlns:a16="http://schemas.microsoft.com/office/drawing/2014/main" id="{40E321FA-63AC-44AA-AF45-C57A4D170A4A}"/>
               </a:ext>
             </a:extLst>
           </p:cNvPr>
@@ -6114,7 +6114,7 @@
           <p:cNvPr id="111" name="water-case">
             <a:extLst xmlns:a="http://schemas.openxmlformats.org/drawingml/2006/main">
               <a:ext uri="{FF2B5EF4-FFF2-40B4-BE49-F238E27FC236}">
-                <a16:creationId xmlns:a16="http://schemas.microsoft.com/office/drawing/2014/main" id="{D2361573-ABA8-4153-A3A4-F31D7CDCAECE}"/>
+                <a16:creationId xmlns:a16="http://schemas.microsoft.com/office/drawing/2014/main" id="{7E8BF332-D900-45A3-8EF0-08DC216A781C}"/>
               </a:ext>
             </a:extLst>
           </p:cNvPr>
@@ -6186,7 +6186,7 @@
           <p:cNvPr id="112" name="case-boundary">
             <a:extLst xmlns:a="http://schemas.openxmlformats.org/drawingml/2006/main">
               <a:ext uri="{FF2B5EF4-FFF2-40B4-BE49-F238E27FC236}">
-                <a16:creationId xmlns:a16="http://schemas.microsoft.com/office/drawing/2014/main" id="{8B5AC735-8DE7-42BA-B996-5F0F9E089E3A}"/>
+                <a16:creationId xmlns:a16="http://schemas.microsoft.com/office/drawing/2014/main" id="{2E95563D-8D9E-472F-8E74-79D8D15FE22C}"/>
               </a:ext>
             </a:extLst>
           </p:cNvPr>
@@ -6285,7 +6285,7 @@
           <p:cNvPr id="113" name="held-same">
             <a:extLst xmlns:a="http://schemas.openxmlformats.org/drawingml/2006/main">
               <a:ext uri="{FF2B5EF4-FFF2-40B4-BE49-F238E27FC236}">
-                <a16:creationId xmlns:a16="http://schemas.microsoft.com/office/drawing/2014/main" id="{51579019-463D-4E2B-B193-4C2E20D6D1A7}"/>
+                <a16:creationId xmlns:a16="http://schemas.microsoft.com/office/drawing/2014/main" id="{89357D36-9D85-4D96-941C-2185CFF1C476}"/>
               </a:ext>
             </a:extLst>
           </p:cNvPr>
@@ -6357,7 +6357,7 @@
           <p:cNvPr id="114" name="held-cross">
             <a:extLst xmlns:a="http://schemas.openxmlformats.org/drawingml/2006/main">
               <a:ext uri="{FF2B5EF4-FFF2-40B4-BE49-F238E27FC236}">
-                <a16:creationId xmlns:a16="http://schemas.microsoft.com/office/drawing/2014/main" id="{B8C2E305-FA94-4E17-B7B2-157E7F6E9369}"/>
+                <a16:creationId xmlns:a16="http://schemas.microsoft.com/office/drawing/2014/main" id="{ECC24D63-921A-4DFB-8F15-3D664AA5C303}"/>
               </a:ext>
             </a:extLst>
           </p:cNvPr>
@@ -6429,7 +6429,7 @@
           <p:cNvPr id="115" name="held-definition">
             <a:extLst xmlns:a="http://schemas.openxmlformats.org/drawingml/2006/main">
               <a:ext uri="{FF2B5EF4-FFF2-40B4-BE49-F238E27FC236}">
-                <a16:creationId xmlns:a16="http://schemas.microsoft.com/office/drawing/2014/main" id="{84E10B42-EB02-4832-981E-B47814E9567D}"/>
+                <a16:creationId xmlns:a16="http://schemas.microsoft.com/office/drawing/2014/main" id="{E3D0F98B-1B20-451D-927E-824B20C5D076}"/>
               </a:ext>
             </a:extLst>
           </p:cNvPr>
@@ -6501,7 +6501,7 @@
           <p:cNvPr id="116" name="Chart">
             <a:extLst xmlns:a="http://schemas.openxmlformats.org/drawingml/2006/main">
               <a:ext uri="{FF2B5EF4-FFF2-40B4-BE49-F238E27FC236}">
-                <a16:creationId xmlns:a16="http://schemas.microsoft.com/office/drawing/2014/main" id="{692F3887-9B7F-402E-B17D-7E52C286877B}"/>
+                <a16:creationId xmlns:a16="http://schemas.microsoft.com/office/drawing/2014/main" id="{067DBE61-B1E5-402E-A86E-42223FADC449}"/>
               </a:ext>
             </a:extLst>
           </p:cNvPr>
@@ -6514,7 +6514,7 @@
         </p:xfrm>
         <a:graphic xmlns:a="http://schemas.openxmlformats.org/drawingml/2006/main">
           <a:graphicData uri="http://schemas.openxmlformats.org/drawingml/2006/chart">
-            <c:chart xmlns:r="http://schemas.openxmlformats.org/officeDocument/2006/relationships" xmlns:c="http://schemas.openxmlformats.org/drawingml/2006/chart" r:id="R2606dbb01b854fcc"/>
+            <c:chart xmlns:r="http://schemas.openxmlformats.org/officeDocument/2006/relationships" xmlns:c="http://schemas.openxmlformats.org/drawingml/2006/chart" r:id="Rf8772d5fba474d13"/>
           </a:graphicData>
         </a:graphic>
       </p:graphicFrame>
@@ -6523,7 +6523,7 @@
           <p:cNvPr id="117" name="future-title-0">
             <a:extLst xmlns:a="http://schemas.openxmlformats.org/drawingml/2006/main">
               <a:ext uri="{FF2B5EF4-FFF2-40B4-BE49-F238E27FC236}">
-                <a16:creationId xmlns:a16="http://schemas.microsoft.com/office/drawing/2014/main" id="{DD14F1C5-04E3-4DD5-828F-69E041FE8E59}"/>
+                <a16:creationId xmlns:a16="http://schemas.microsoft.com/office/drawing/2014/main" id="{BC108600-1179-42C1-99CD-2E2E6F6FFF75}"/>
               </a:ext>
             </a:extLst>
           </p:cNvPr>
@@ -6595,7 +6595,7 @@
           <p:cNvPr id="118" name="future-detail-0">
             <a:extLst xmlns:a="http://schemas.openxmlformats.org/drawingml/2006/main">
               <a:ext uri="{FF2B5EF4-FFF2-40B4-BE49-F238E27FC236}">
-                <a16:creationId xmlns:a16="http://schemas.microsoft.com/office/drawing/2014/main" id="{0D026279-FB67-4E16-9482-56C285F65859}"/>
+                <a16:creationId xmlns:a16="http://schemas.microsoft.com/office/drawing/2014/main" id="{F4D870D1-7930-4608-9E59-8298D0C5268B}"/>
               </a:ext>
             </a:extLst>
           </p:cNvPr>
@@ -6721,7 +6721,7 @@
           <p:cNvPr id="119" name="future-title-1">
             <a:extLst xmlns:a="http://schemas.openxmlformats.org/drawingml/2006/main">
               <a:ext uri="{FF2B5EF4-FFF2-40B4-BE49-F238E27FC236}">
-                <a16:creationId xmlns:a16="http://schemas.microsoft.com/office/drawing/2014/main" id="{E263DE54-739B-46FF-915C-6E3F9562D090}"/>
+                <a16:creationId xmlns:a16="http://schemas.microsoft.com/office/drawing/2014/main" id="{9A0D2293-7A76-466E-A357-1E05E82C053E}"/>
               </a:ext>
             </a:extLst>
           </p:cNvPr>
@@ -6793,7 +6793,7 @@
           <p:cNvPr id="120" name="future-detail-1">
             <a:extLst xmlns:a="http://schemas.openxmlformats.org/drawingml/2006/main">
               <a:ext uri="{FF2B5EF4-FFF2-40B4-BE49-F238E27FC236}">
-                <a16:creationId xmlns:a16="http://schemas.microsoft.com/office/drawing/2014/main" id="{AE2B873B-4D5E-45E2-90D9-0A12A99947F4}"/>
+                <a16:creationId xmlns:a16="http://schemas.microsoft.com/office/drawing/2014/main" id="{3FC64FDA-9CD8-4EC8-A92C-E63A50FBF724}"/>
               </a:ext>
             </a:extLst>
           </p:cNvPr>
@@ -6919,7 +6919,7 @@
           <p:cNvPr id="121" name="future-title-2">
             <a:extLst xmlns:a="http://schemas.openxmlformats.org/drawingml/2006/main">
               <a:ext uri="{FF2B5EF4-FFF2-40B4-BE49-F238E27FC236}">
-                <a16:creationId xmlns:a16="http://schemas.microsoft.com/office/drawing/2014/main" id="{F7EB4674-869B-4545-934E-F30033A2ED7E}"/>
+                <a16:creationId xmlns:a16="http://schemas.microsoft.com/office/drawing/2014/main" id="{10AC8790-15AF-496F-9D03-C65333B97C72}"/>
               </a:ext>
             </a:extLst>
           </p:cNvPr>
@@ -6991,7 +6991,7 @@
           <p:cNvPr id="122" name="future-detail-2">
             <a:extLst xmlns:a="http://schemas.openxmlformats.org/drawingml/2006/main">
               <a:ext uri="{FF2B5EF4-FFF2-40B4-BE49-F238E27FC236}">
-                <a16:creationId xmlns:a16="http://schemas.microsoft.com/office/drawing/2014/main" id="{38BD8955-DD63-4D53-B0B6-9871F011A39F}"/>
+                <a16:creationId xmlns:a16="http://schemas.microsoft.com/office/drawing/2014/main" id="{B2E13272-5BDA-4D3D-9241-77D350926129}"/>
               </a:ext>
             </a:extLst>
           </p:cNvPr>
@@ -7117,7 +7117,7 @@
           <p:cNvPr id="123" name="future-title-3">
             <a:extLst xmlns:a="http://schemas.openxmlformats.org/drawingml/2006/main">
               <a:ext uri="{FF2B5EF4-FFF2-40B4-BE49-F238E27FC236}">
-                <a16:creationId xmlns:a16="http://schemas.microsoft.com/office/drawing/2014/main" id="{894F0AE9-A4F9-4412-AB43-1A63DFC42F43}"/>
+                <a16:creationId xmlns:a16="http://schemas.microsoft.com/office/drawing/2014/main" id="{38F60E3E-382B-4769-9EAD-D9808298FFB8}"/>
               </a:ext>
             </a:extLst>
           </p:cNvPr>
@@ -7189,7 +7189,7 @@
           <p:cNvPr id="124" name="future-detail-3">
             <a:extLst xmlns:a="http://schemas.openxmlformats.org/drawingml/2006/main">
               <a:ext uri="{FF2B5EF4-FFF2-40B4-BE49-F238E27FC236}">
-                <a16:creationId xmlns:a16="http://schemas.microsoft.com/office/drawing/2014/main" id="{1341E642-6E54-4B36-8EA8-27BC0004D38F}"/>
+                <a16:creationId xmlns:a16="http://schemas.microsoft.com/office/drawing/2014/main" id="{87C2BFFC-1409-4E48-BF05-CA529C8C2FB5}"/>
               </a:ext>
             </a:extLst>
           </p:cNvPr>

</xml_diff>